<commit_message>
Update repository and documentation for MEDIQ
</commit_message>
<xml_diff>
--- a/documents/Presentation-1.pptx
+++ b/documents/Presentation-1.pptx
@@ -226,7 +226,7 @@
           <a:p>
             <a:fld id="{DE949122-5B3E-46D7-88DF-4A6E0C399539}" type="datetimeFigureOut">
               <a:rPr lang="gu-IN" smtClean="0"/>
-              <a:t>04-04-26</a:t>
+              <a:t>01-05-26</a:t>
             </a:fld>
             <a:endParaRPr lang="gu-IN"/>
           </a:p>
@@ -643,7 +643,7 @@
           <a:p>
             <a:fld id="{C1FE01AB-D1ED-4D26-8DF6-DA51406BF7F7}" type="datetime1">
               <a:rPr lang="gu-IN" smtClean="0"/>
-              <a:t>04-04-26</a:t>
+              <a:t>01-05-26</a:t>
             </a:fld>
             <a:endParaRPr lang="gu-IN"/>
           </a:p>
@@ -843,7 +843,7 @@
           <a:p>
             <a:fld id="{6053DC65-D5AC-4E23-992E-E506D99377A5}" type="datetime1">
               <a:rPr lang="gu-IN" smtClean="0"/>
-              <a:t>04-04-26</a:t>
+              <a:t>01-05-26</a:t>
             </a:fld>
             <a:endParaRPr lang="gu-IN"/>
           </a:p>
@@ -1053,7 +1053,7 @@
           <a:p>
             <a:fld id="{E70BEBE6-834A-47B9-9859-7050070988AF}" type="datetime1">
               <a:rPr lang="gu-IN" smtClean="0"/>
-              <a:t>04-04-26</a:t>
+              <a:t>01-05-26</a:t>
             </a:fld>
             <a:endParaRPr lang="gu-IN"/>
           </a:p>
@@ -1253,7 +1253,7 @@
           <a:p>
             <a:fld id="{73C1B614-61C2-4055-9C06-B48C0071E54D}" type="datetime1">
               <a:rPr lang="gu-IN" smtClean="0"/>
-              <a:t>04-04-26</a:t>
+              <a:t>01-05-26</a:t>
             </a:fld>
             <a:endParaRPr lang="gu-IN"/>
           </a:p>
@@ -1529,7 +1529,7 @@
           <a:p>
             <a:fld id="{0ECA5429-D273-4622-9956-1B038DA8CC78}" type="datetime1">
               <a:rPr lang="gu-IN" smtClean="0"/>
-              <a:t>04-04-26</a:t>
+              <a:t>01-05-26</a:t>
             </a:fld>
             <a:endParaRPr lang="gu-IN"/>
           </a:p>
@@ -1797,7 +1797,7 @@
           <a:p>
             <a:fld id="{4A02CBE6-E2D6-43D7-9C0E-035136A6F097}" type="datetime1">
               <a:rPr lang="gu-IN" smtClean="0"/>
-              <a:t>04-04-26</a:t>
+              <a:t>01-05-26</a:t>
             </a:fld>
             <a:endParaRPr lang="gu-IN"/>
           </a:p>
@@ -2212,7 +2212,7 @@
           <a:p>
             <a:fld id="{80C4000C-9E58-4598-918C-05BE8F286DE9}" type="datetime1">
               <a:rPr lang="gu-IN" smtClean="0"/>
-              <a:t>04-04-26</a:t>
+              <a:t>01-05-26</a:t>
             </a:fld>
             <a:endParaRPr lang="gu-IN"/>
           </a:p>
@@ -2354,7 +2354,7 @@
           <a:p>
             <a:fld id="{F7526C5A-8DD2-49C6-A634-2ECA94FB85AB}" type="datetime1">
               <a:rPr lang="gu-IN" smtClean="0"/>
-              <a:t>04-04-26</a:t>
+              <a:t>01-05-26</a:t>
             </a:fld>
             <a:endParaRPr lang="gu-IN"/>
           </a:p>
@@ -2467,7 +2467,7 @@
           <a:p>
             <a:fld id="{53843BCE-9F5A-43F7-AE72-F6FADD6A1BB6}" type="datetime1">
               <a:rPr lang="gu-IN" smtClean="0"/>
-              <a:t>04-04-26</a:t>
+              <a:t>01-05-26</a:t>
             </a:fld>
             <a:endParaRPr lang="gu-IN"/>
           </a:p>
@@ -2780,7 +2780,7 @@
           <a:p>
             <a:fld id="{B9FFB065-F016-4585-8DF8-6AB802053FED}" type="datetime1">
               <a:rPr lang="gu-IN" smtClean="0"/>
-              <a:t>04-04-26</a:t>
+              <a:t>01-05-26</a:t>
             </a:fld>
             <a:endParaRPr lang="gu-IN"/>
           </a:p>
@@ -3069,7 +3069,7 @@
           <a:p>
             <a:fld id="{652EE017-4797-4E82-B477-5D61EEC095E6}" type="datetime1">
               <a:rPr lang="gu-IN" smtClean="0"/>
-              <a:t>04-04-26</a:t>
+              <a:t>01-05-26</a:t>
             </a:fld>
             <a:endParaRPr lang="gu-IN"/>
           </a:p>
@@ -3312,7 +3312,7 @@
           <a:p>
             <a:fld id="{F08D26A1-E9F8-435F-9CA1-79C9D30855F8}" type="datetime1">
               <a:rPr lang="gu-IN" smtClean="0"/>
-              <a:t>04-04-26</a:t>
+              <a:t>01-05-26</a:t>
             </a:fld>
             <a:endParaRPr lang="gu-IN"/>
           </a:p>

</xml_diff>